<commit_message>
Centre quote text vertically; take tycoslide 0.14.1
The Quote and Testimonial quote shapes anchored to the top of their
cards; they now anchor to the centre. Three attributes in the template,
nothing else. The lockfile picks up 0.14.1, which keeps blank lines in
code fences.

Co-Authored-By: Claude Fable 5.1 <noreply@anthropic.com>
</commit_message>
<xml_diff>
--- a/template/tycoworks-demo.pptx
+++ b/template/tycoworks-demo.pptx
@@ -16848,7 +16848,7 @@
           </a:prstGeom>
         </p:spPr>
         <p:txBody>
-          <a:bodyPr anchorCtr="0" anchor="t" bIns="0" lIns="0" spcFirstLastPara="1" rIns="0" wrap="square" tIns="0">
+          <a:bodyPr anchorCtr="0" anchor="ctr" bIns="0" lIns="0" spcFirstLastPara="1" rIns="0" wrap="square" tIns="0">
             <a:normAutofit/>
           </a:bodyPr>
           <a:lstStyle/>
@@ -17120,7 +17120,7 @@
           </a:prstGeom>
         </p:spPr>
         <p:txBody>
-          <a:bodyPr anchorCtr="0" anchor="t" bIns="0" lIns="182875" spcFirstLastPara="1" rIns="182875" wrap="square" tIns="182875">
+          <a:bodyPr anchorCtr="0" anchor="ctr" bIns="0" lIns="182875" spcFirstLastPara="1" rIns="182875" wrap="square" tIns="182875">
             <a:normAutofit/>
           </a:bodyPr>
           <a:lstStyle/>
@@ -17241,7 +17241,7 @@
           </a:prstGeom>
         </p:spPr>
         <p:txBody>
-          <a:bodyPr anchorCtr="0" anchor="t" bIns="0" lIns="182875" spcFirstLastPara="1" rIns="182875" wrap="square" tIns="182875">
+          <a:bodyPr anchorCtr="0" anchor="ctr" bIns="0" lIns="182875" spcFirstLastPara="1" rIns="182875" wrap="square" tIns="182875">
             <a:normAutofit/>
           </a:bodyPr>
           <a:lstStyle/>

</xml_diff>

<commit_message>
Add the how-it-works deck; drop picture placeholders from the template
how-it-works.md is the deck the tycoslide README points at: a timeline,
a code slide showing the markdown of the slide after it, a mermaid tree,
and speaker notes. The three image layouts carried empty picture
placeholders from Google Slides that Keynote rejected and LibreOffice
drew behind the real pictures; they and the tags that referenced them
are removed, with identical renders. README spelling is US.

Co-Authored-By: Claude Fable 5.1 <noreply@anthropic.com>
</commit_message>
<xml_diff>
--- a/template/tycoworks-demo.pptx
+++ b/template/tycoworks-demo.pptx
@@ -5551,30 +5551,6 @@
       </p:grpSpPr>
       <p:sp>
         <p:nvSpPr>
-          <p:cNvPr id="231" name="Google Shape;231;p30"/>
-          <p:cNvSpPr/>
-          <p:nvPr>
-            <p:ph idx="2" type="pic"/>
-          </p:nvPr>
-        </p:nvSpPr>
-        <p:spPr>
-          <a:xfrm>
-            <a:off x="4654125" y="454950"/>
-            <a:ext cx="4489800" cy="4233600"/>
-          </a:xfrm>
-          <a:prstGeom prst="roundRect">
-            <a:avLst>
-              <a:gd fmla="val 0" name="adj"/>
-            </a:avLst>
-          </a:prstGeom>
-          <a:noFill/>
-          <a:ln>
-            <a:noFill/>
-          </a:ln>
-        </p:spPr>
-      </p:sp>
-      <p:sp>
-        <p:nvSpPr>
           <p:cNvPr id="232" name="Google Shape;232;p30"/>
           <p:cNvSpPr txBox="1"/>
           <p:nvPr>
@@ -6211,30 +6187,6 @@
       </p:grpSpPr>
       <p:sp>
         <p:nvSpPr>
-          <p:cNvPr id="245" name="Google Shape;245;p32"/>
-          <p:cNvSpPr/>
-          <p:nvPr>
-            <p:ph idx="2" type="pic"/>
-          </p:nvPr>
-        </p:nvSpPr>
-        <p:spPr>
-          <a:xfrm>
-            <a:off x="0" y="457200"/>
-            <a:ext cx="4489800" cy="4233600"/>
-          </a:xfrm>
-          <a:prstGeom prst="roundRect">
-            <a:avLst>
-              <a:gd fmla="val 0" name="adj"/>
-            </a:avLst>
-          </a:prstGeom>
-          <a:noFill/>
-          <a:ln>
-            <a:noFill/>
-          </a:ln>
-        </p:spPr>
-      </p:sp>
-      <p:sp>
-        <p:nvSpPr>
           <p:cNvPr id="246" name="Google Shape;246;p32"/>
           <p:cNvSpPr txBox="1"/>
           <p:nvPr>
@@ -6864,28 +6816,6 @@
           <a:chExt cx="0" cy="0"/>
         </a:xfrm>
       </p:grpSpPr>
-      <p:sp>
-        <p:nvSpPr>
-          <p:cNvPr id="258" name="Google Shape;258;p34"/>
-          <p:cNvSpPr/>
-          <p:nvPr>
-            <p:ph idx="2" type="pic"/>
-          </p:nvPr>
-        </p:nvSpPr>
-        <p:spPr>
-          <a:xfrm>
-            <a:off x="-150" y="0"/>
-            <a:ext cx="9144300" cy="4690800"/>
-          </a:xfrm>
-          <a:prstGeom prst="rect">
-            <a:avLst/>
-          </a:prstGeom>
-          <a:noFill/>
-          <a:ln>
-            <a:noFill/>
-          </a:ln>
-        </p:spPr>
-      </p:sp>
       <p:sp>
         <p:nvSpPr>
           <p:cNvPr id="259" name="Google Shape;259;p34"/>
@@ -16630,9 +16560,7 @@
         <p:nvPicPr>
           <p:cNvPr id="869" name="Google Shape;869;p94" title="mz-presentation_bkg-isometric_grid-boxes-light.jpg"/>
           <p:cNvPicPr preferRelativeResize="0"/>
-          <p:nvPr>
-            <p:ph idx="2" type="pic"/>
-          </p:nvPr>
+          <p:nvPr/>
         </p:nvPicPr>
         <p:blipFill rotWithShape="1">
           <a:blip r:embed="rId3">
@@ -24677,9 +24605,7 @@
         <p:nvPicPr>
           <p:cNvPr id="777" name="Google Shape;777;p86" title="mz-presentation_bkg-isometric_grid-boxes-light.jpg"/>
           <p:cNvPicPr preferRelativeResize="0"/>
-          <p:nvPr>
-            <p:ph idx="2" type="pic"/>
-          </p:nvPr>
+          <p:nvPr/>
         </p:nvPicPr>
         <p:blipFill rotWithShape="1">
           <a:blip r:embed="rId3">
@@ -24881,9 +24807,7 @@
         <p:nvPicPr>
           <p:cNvPr id="853" name="Google Shape;853;p92" title="mz-presentation_bkg-isometric_grid-boxes-light.jpg"/>
           <p:cNvPicPr preferRelativeResize="0"/>
-          <p:nvPr>
-            <p:ph idx="2" type="pic"/>
-          </p:nvPr>
+          <p:nvPr/>
         </p:nvPicPr>
         <p:blipFill rotWithShape="1">
           <a:blip r:embed="rId3">

</xml_diff>

<commit_message>
Clear stale placeholder alt-text titles from the template
The same thing the engine now does on output.

Co-Authored-By: Claude Opus 5.5 <noreply@anthropic.com>
</commit_message>
<xml_diff>
--- a/template/tycoworks-demo.pptx
+++ b/template/tycoworks-demo.pptx
@@ -16558,7 +16558,7 @@
       </p:sp>
       <p:pic>
         <p:nvPicPr>
-          <p:cNvPr id="869" name="Google Shape;869;p94" title="mz-presentation_bkg-isometric_grid-boxes-light.jpg"/>
+          <p:cNvPr id="869" name="Google Shape;869;p94"/>
           <p:cNvPicPr preferRelativeResize="0"/>
           <p:nvPr/>
         </p:nvPicPr>
@@ -24603,7 +24603,7 @@
       </p:grpSpPr>
       <p:pic>
         <p:nvPicPr>
-          <p:cNvPr id="777" name="Google Shape;777;p86" title="mz-presentation_bkg-isometric_grid-boxes-light.jpg"/>
+          <p:cNvPr id="777" name="Google Shape;777;p86"/>
           <p:cNvPicPr preferRelativeResize="0"/>
           <p:nvPr/>
         </p:nvPicPr>
@@ -24805,7 +24805,7 @@
       </p:sp>
       <p:pic>
         <p:nvPicPr>
-          <p:cNvPr id="853" name="Google Shape;853;p92" title="mz-presentation_bkg-isometric_grid-boxes-light.jpg"/>
+          <p:cNvPr id="853" name="Google Shape;853;p92"/>
           <p:cNvPicPr preferRelativeResize="0"/>
           <p:nvPr/>
         </p:nvPicPr>

</xml_diff>